<commit_message>
Put the docs site URL on the deck
Title footer and the closing slide, which is the one people photograph.

Co-Authored-By: Claude Opus 5 <noreply@anthropic.com>
Claude-Session: https://claude.ai/code/session_016m8oA6R9RV6DwVJS2wFFur
</commit_message>
<xml_diff>
--- a/herestuck_boat_build_day.pptx
+++ b/herestuck_boat_build_day.pptx
@@ -3312,7 +3312,7 @@
         <p:spPr>
           <a:xfrm>
             <a:off x="822960" y="6272784"/>
-            <a:ext cx="8229600" cy="274320"/>
+            <a:ext cx="10424160" cy="274320"/>
           </a:xfrm>
           <a:prstGeom prst="rect">
             <a:avLst/>
@@ -3333,7 +3333,7 @@
                 </a:solidFill>
                 <a:latin typeface="Menlo"/>
               </a:rPr>
-              <a:t>ASA OVER GYROID, FIBERGLASSED AFTER   ·   REV-3.4</a:t>
+              <a:t>ASA OVER GYROID, FIBERGLASSED AFTER   ·   REV-3.4   ·   ALEXWYNN-AM.GITHUB.IO/BOAT-DESIGN</a:t>
             </a:r>
           </a:p>
         </p:txBody>
@@ -4157,7 +4157,7 @@
         </p:nvSpPr>
         <p:spPr>
           <a:xfrm>
-            <a:off x="822960" y="4434840"/>
+            <a:off x="822960" y="4315968"/>
             <a:ext cx="6217920" cy="1188720"/>
           </a:xfrm>
           <a:prstGeom prst="rect">
@@ -4190,7 +4190,86 @@
       </p:sp>
       <p:sp>
         <p:nvSpPr>
-          <p:cNvPr id="5" name="TextBox 4"/>
+          <p:cNvPr id="5" name="Rectangle 4"/>
+          <p:cNvSpPr/>
+          <p:nvPr/>
+        </p:nvSpPr>
+        <p:spPr>
+          <a:xfrm>
+            <a:off x="822960" y="5440680"/>
+            <a:ext cx="566928" cy="41148"/>
+          </a:xfrm>
+          <a:prstGeom prst="rect">
+            <a:avLst/>
+          </a:prstGeom>
+          <a:solidFill>
+            <a:srgbClr val="E4572E"/>
+          </a:solidFill>
+          <a:ln>
+            <a:noFill/>
+          </a:ln>
+          <a:effectLst/>
+        </p:spPr>
+        <p:style>
+          <a:lnRef idx="1">
+            <a:schemeClr val="accent1"/>
+          </a:lnRef>
+          <a:fillRef idx="3">
+            <a:schemeClr val="accent1"/>
+          </a:fillRef>
+          <a:effectRef idx="2">
+            <a:schemeClr val="accent1"/>
+          </a:effectRef>
+          <a:fontRef idx="minor">
+            <a:schemeClr val="lt1"/>
+          </a:fontRef>
+        </p:style>
+        <p:txBody>
+          <a:bodyPr rtlCol="0" anchor="ctr"/>
+          <a:lstStyle/>
+          <a:p>
+            <a:pPr algn="ctr"/>
+          </a:p>
+        </p:txBody>
+      </p:sp>
+      <p:sp>
+        <p:nvSpPr>
+          <p:cNvPr id="6" name="TextBox 5"/>
+          <p:cNvSpPr txBox="1"/>
+          <p:nvPr/>
+        </p:nvSpPr>
+        <p:spPr>
+          <a:xfrm>
+            <a:off x="822960" y="5632704"/>
+            <a:ext cx="8229600" cy="411480"/>
+          </a:xfrm>
+          <a:prstGeom prst="rect">
+            <a:avLst/>
+          </a:prstGeom>
+          <a:noFill/>
+        </p:spPr>
+        <p:txBody>
+          <a:bodyPr wrap="square" lIns="0" rIns="0" tIns="0" bIns="0">
+            <a:spAutoFit/>
+          </a:bodyPr>
+          <a:lstStyle/>
+          <a:p>
+            <a:pPr algn="l"/>
+            <a:r>
+              <a:rPr sz="2200" b="1">
+                <a:solidFill>
+                  <a:srgbClr val="E4572E"/>
+                </a:solidFill>
+                <a:latin typeface="Helvetica Neue"/>
+              </a:rPr>
+              <a:t>alexwynn-am.github.io/boat-design</a:t>
+            </a:r>
+          </a:p>
+        </p:txBody>
+      </p:sp>
+      <p:sp>
+        <p:nvSpPr>
+          <p:cNvPr id="7" name="TextBox 6"/>
           <p:cNvSpPr txBox="1"/>
           <p:nvPr/>
         </p:nvSpPr>

</xml_diff>